<commit_message>
Wrap up accessbility pass. Yay!
</commit_message>
<xml_diff>
--- a/lectures/07-Emulator.pptx
+++ b/lectures/07-Emulator.pptx
@@ -8056,7 +8056,9 @@
             <a:r>
               <a:rPr lang="en-US" b="1" dirty="0">
                 <a:solidFill>
-                  <a:srgbClr val="00B050"/>
+                  <a:schemeClr val="accent1">
+                    <a:lumMod val="50000"/>
+                  </a:schemeClr>
                 </a:solidFill>
                 <a:effectLst/>
                 <a:latin typeface="Courier New" panose="02070309020205020404" pitchFamily="49" charset="0"/>

</xml_diff>